<commit_message>
Remove company-specific public assumptions and clarify personal authorship
</commit_message>
<xml_diff>
--- a/public/Thomas-Ryan-PepperBall-Platform-Case-Study.pptx
+++ b/public/Thomas-Ryan-PepperBall-Platform-Case-Study.pptx
@@ -2,20 +2,20 @@
 <file path=ppt/presentation.xml><?xml version="1.0" encoding="utf-8"?>
 <p:presentation xmlns:p="http://schemas.openxmlformats.org/presentationml/2006/main">
   <p:sldMasterIdLst>
-    <p:sldMasterId xmlns:r="http://schemas.openxmlformats.org/officeDocument/2006/relationships" id="2147483648" r:id="Rad6e5ebb66f94253"/>
+    <p:sldMasterId xmlns:r="http://schemas.openxmlformats.org/officeDocument/2006/relationships" id="2147483648" r:id="Rdbee9fdcda45464f"/>
   </p:sldMasterIdLst>
   <p:notesMasterIdLst>
-    <p:notesMasterId xmlns:r="http://schemas.openxmlformats.org/officeDocument/2006/relationships" r:id="Re478cfb7f0e54ca5"/>
+    <p:notesMasterId xmlns:r="http://schemas.openxmlformats.org/officeDocument/2006/relationships" r:id="R061c3f73cc0641eb"/>
   </p:notesMasterIdLst>
   <p:sldIdLst>
-    <p:sldId xmlns:r="http://schemas.openxmlformats.org/officeDocument/2006/relationships" id="256" r:id="Rf0a588de4cd649b1"/>
-    <p:sldId xmlns:r="http://schemas.openxmlformats.org/officeDocument/2006/relationships" id="257" r:id="Rb1e6c9ef35ac4534"/>
-    <p:sldId xmlns:r="http://schemas.openxmlformats.org/officeDocument/2006/relationships" id="258" r:id="Rd6a8ed493b0a4cd6"/>
-    <p:sldId xmlns:r="http://schemas.openxmlformats.org/officeDocument/2006/relationships" id="259" r:id="R9a4d3cea54e04c87"/>
-    <p:sldId xmlns:r="http://schemas.openxmlformats.org/officeDocument/2006/relationships" id="260" r:id="Ra5d2b1f247904452"/>
-    <p:sldId xmlns:r="http://schemas.openxmlformats.org/officeDocument/2006/relationships" id="261" r:id="Rd3b88cc976f14e77"/>
-    <p:sldId xmlns:r="http://schemas.openxmlformats.org/officeDocument/2006/relationships" id="262" r:id="R2b375dbb2bfd466a"/>
-    <p:sldId xmlns:r="http://schemas.openxmlformats.org/officeDocument/2006/relationships" id="263" r:id="Re1f8543c0ab64b4d"/>
+    <p:sldId xmlns:r="http://schemas.openxmlformats.org/officeDocument/2006/relationships" id="256" r:id="Ra0e54e4230fd4b55"/>
+    <p:sldId xmlns:r="http://schemas.openxmlformats.org/officeDocument/2006/relationships" id="257" r:id="R6c5c1ebbbbcb441b"/>
+    <p:sldId xmlns:r="http://schemas.openxmlformats.org/officeDocument/2006/relationships" id="258" r:id="Ra0a227da42dd4d72"/>
+    <p:sldId xmlns:r="http://schemas.openxmlformats.org/officeDocument/2006/relationships" id="259" r:id="Rbee04b4477e84939"/>
+    <p:sldId xmlns:r="http://schemas.openxmlformats.org/officeDocument/2006/relationships" id="260" r:id="R05540dba719c45eb"/>
+    <p:sldId xmlns:r="http://schemas.openxmlformats.org/officeDocument/2006/relationships" id="261" r:id="R649e385a8f064e66"/>
+    <p:sldId xmlns:r="http://schemas.openxmlformats.org/officeDocument/2006/relationships" id="262" r:id="R026e95b253e94806"/>
+    <p:sldId xmlns:r="http://schemas.openxmlformats.org/officeDocument/2006/relationships" id="263" r:id="R429c2d5c00604344"/>
   </p:sldIdLst>
   <p:sldSz cx="12192000" cy="6858000"/>
   <p:notesSz cx="6858000" cy="9144000"/>
@@ -1237,7 +1237,7 @@
   </p:cSld>
   <p:clrMap bg1="lt1" tx1="dk1" bg2="lt2" tx2="dk2" accent1="accent1" accent2="accent2" accent3="accent3" accent4="accent4" accent5="accent5" accent6="accent6" hlink="hlink" folHlink="folHlink"/>
   <p:sldLayoutIdLst>
-    <p:sldLayoutId xmlns:r="http://schemas.openxmlformats.org/officeDocument/2006/relationships" id="2147483649" r:id="Ra600d3afa4e24879"/>
+    <p:sldLayoutId xmlns:r="http://schemas.openxmlformats.org/officeDocument/2006/relationships" id="2147483649" r:id="R63bcd5319a5f4142"/>
   </p:sldLayoutIdLst>
   <p:txStyles>
     <p:titleStyle>
@@ -1837,7 +1837,7 @@
                 <a:ea typeface="Aptos"/>
                 <a:cs typeface="Aptos"/>
               </a:rPr>
-              <a:t>PEPPERBALL ENGINEERING CASE STUDY</a:t>
+              <a:t>THOMAS RYAN / PEPPERBALL INTERNSHIP CASE STUDY</a:t>
             </a:r>
           </a:p>
         </p:txBody>
@@ -2133,6 +2133,62 @@
                 <a:cs typeface="Aptos"/>
               </a:rPr>
               <a:t>May-August 2026</a:t>
+            </a:r>
+          </a:p>
+        </p:txBody>
+      </p:sp>
+      <p:sp>
+        <p:nvSpPr>
+          <p:cNvPr id="8" name="">
+            <a:extLst xmlns:a="http://schemas.openxmlformats.org/drawingml/2006/main">
+              <a:ext uri="{FF2B5EF4-FFF2-40B4-BE49-F238E27FC236}">
+                <a16:creationId xmlns:a16="http://schemas.microsoft.com/office/drawing/2014/main" id="{711CFBE5-2326-4A02-AE15-0EF18BF1EC4E}"/>
+              </a:ext>
+            </a:extLst>
+          </p:cNvPr>
+          <p:cNvSpPr>
+            <a:spLocks xmlns:a="http://schemas.openxmlformats.org/drawingml/2006/main" noGrp="1"/>
+          </p:cNvSpPr>
+          <p:nvPr/>
+        </p:nvSpPr>
+        <p:spPr>
+          <a:xfrm xmlns:a="http://schemas.openxmlformats.org/drawingml/2006/main">
+            <a:off x="400050" y="6419850"/>
+            <a:ext cx="10668000" cy="209550"/>
+          </a:xfrm>
+          <a:prstGeom xmlns:a="http://schemas.openxmlformats.org/drawingml/2006/main" prst="rect">
+            <a:avLst/>
+          </a:prstGeom>
+          <a:noFill xmlns:a="http://schemas.openxmlformats.org/drawingml/2006/main"/>
+          <a:ln xmlns:a="http://schemas.openxmlformats.org/drawingml/2006/main" w="0">
+            <a:noFill/>
+          </a:ln>
+        </p:spPr>
+        <p:txBody>
+          <a:bodyPr xmlns:a="http://schemas.openxmlformats.org/drawingml/2006/main"/>
+          <a:lstStyle xmlns:a="http://schemas.openxmlformats.org/drawingml/2006/main"/>
+          <a:p xmlns:a="http://schemas.openxmlformats.org/drawingml/2006/main">
+            <a:pPr>
+              <a:buNone/>
+              <a:defRPr sz="900">
+                <a:solidFill>
+                  <a:srgbClr val="626262"/>
+                </a:solidFill>
+                <a:latin typeface="Arial"/>
+                <a:ea typeface="Arial"/>
+                <a:cs typeface="Arial"/>
+              </a:defRPr>
+            </a:pPr>
+            <a:r>
+              <a:rPr sz="900">
+                <a:solidFill>
+                  <a:srgbClr val="626262"/>
+                </a:solidFill>
+                <a:latin typeface="Arial"/>
+                <a:ea typeface="Arial"/>
+                <a:cs typeface="Arial"/>
+              </a:rPr>
+              <a:t>Personal portfolio case study by Thomas Ryan. Not an official PepperBall publication.</a:t>
             </a:r>
           </a:p>
         </p:txBody>
@@ -2345,7 +2401,7 @@
       </p:sp>
       <p:cxnSp>
         <p:nvCxnSpPr>
-          <p:cNvPr id="34" name=""/>
+          <p:cNvPr id="42" name=""/>
           <p:cNvCxnSpPr/>
           <p:nvPr/>
         </p:nvCxnSpPr>
@@ -2419,7 +2475,7 @@
                 <a:ea typeface="Aptos"/>
                 <a:cs typeface="Aptos"/>
               </a:rPr>
-              <a:t>PEPPERBALL REPORTING PLATFORM</a:t>
+              <a:t>THOMAS RYAN</a:t>
             </a:r>
           </a:p>
         </p:txBody>
@@ -3539,7 +3595,7 @@
       </p:sp>
       <p:cxnSp>
         <p:nvCxnSpPr>
-          <p:cNvPr id="142" name=""/>
+          <p:cNvPr id="234" name=""/>
           <p:cNvCxnSpPr/>
           <p:nvPr/>
         </p:nvCxnSpPr>
@@ -3613,7 +3669,7 @@
                 <a:ea typeface="Aptos"/>
                 <a:cs typeface="Aptos"/>
               </a:rPr>
-              <a:t>PEPPERBALL REPORTING PLATFORM</a:t>
+              <a:t>THOMAS RYAN</a:t>
             </a:r>
           </a:p>
         </p:txBody>
@@ -3891,7 +3947,7 @@
       </p:sp>
       <p:cxnSp>
         <p:nvCxnSpPr>
-          <p:cNvPr id="149" name=""/>
+          <p:cNvPr id="241" name=""/>
           <p:cNvCxnSpPr/>
           <p:nvPr/>
         </p:nvCxnSpPr>
@@ -4125,7 +4181,7 @@
       </p:sp>
       <p:cxnSp>
         <p:nvCxnSpPr>
-          <p:cNvPr id="154" name=""/>
+          <p:cNvPr id="246" name=""/>
           <p:cNvCxnSpPr/>
           <p:nvPr/>
         </p:nvCxnSpPr>
@@ -4359,7 +4415,7 @@
       </p:sp>
       <p:cxnSp>
         <p:nvCxnSpPr>
-          <p:cNvPr id="159" name=""/>
+          <p:cNvPr id="251" name=""/>
           <p:cNvCxnSpPr/>
           <p:nvPr/>
         </p:nvCxnSpPr>
@@ -4805,7 +4861,7 @@
       </p:sp>
       <p:cxnSp>
         <p:nvCxnSpPr>
-          <p:cNvPr id="168" name=""/>
+          <p:cNvPr id="260" name=""/>
           <p:cNvCxnSpPr/>
           <p:nvPr/>
         </p:nvCxnSpPr>
@@ -5039,7 +5095,7 @@
       </p:sp>
       <p:cxnSp>
         <p:nvCxnSpPr>
-          <p:cNvPr id="173" name=""/>
+          <p:cNvPr id="265" name=""/>
           <p:cNvCxnSpPr/>
           <p:nvPr/>
         </p:nvCxnSpPr>
@@ -5273,7 +5329,7 @@
       </p:sp>
       <p:cxnSp>
         <p:nvCxnSpPr>
-          <p:cNvPr id="178" name=""/>
+          <p:cNvPr id="270" name=""/>
           <p:cNvCxnSpPr/>
           <p:nvPr/>
         </p:nvCxnSpPr>
@@ -5507,7 +5563,7 @@
       </p:sp>
       <p:cxnSp>
         <p:nvCxnSpPr>
-          <p:cNvPr id="183" name=""/>
+          <p:cNvPr id="275" name=""/>
           <p:cNvCxnSpPr/>
           <p:nvPr/>
         </p:nvCxnSpPr>
@@ -5529,7 +5585,7 @@
       </p:cxnSp>
       <p:cxnSp>
         <p:nvCxnSpPr>
-          <p:cNvPr id="184" name=""/>
+          <p:cNvPr id="276" name=""/>
           <p:cNvCxnSpPr/>
           <p:nvPr/>
         </p:nvCxnSpPr>
@@ -5712,8 +5768,8 @@
         </p:nvSpPr>
         <p:spPr>
           <a:xfrm xmlns:a="http://schemas.openxmlformats.org/drawingml/2006/main">
-            <a:off x="400050" y="1638300"/>
-            <a:ext cx="10668000" cy="552450"/>
+            <a:off x="400050" y="1828800"/>
+            <a:ext cx="10668000" cy="457200"/>
           </a:xfrm>
           <a:prstGeom xmlns:a="http://schemas.openxmlformats.org/drawingml/2006/main" prst="rect">
             <a:avLst/>
@@ -5757,7 +5813,7 @@
       </p:sp>
       <p:cxnSp>
         <p:nvCxnSpPr>
-          <p:cNvPr id="35" name=""/>
+          <p:cNvPr id="45" name=""/>
           <p:cNvCxnSpPr/>
           <p:nvPr/>
         </p:nvCxnSpPr>
@@ -5831,7 +5887,7 @@
                 <a:ea typeface="Aptos"/>
                 <a:cs typeface="Aptos"/>
               </a:rPr>
-              <a:t>PEPPERBALL REPORTING PLATFORM</a:t>
+              <a:t>THOMAS RYAN</a:t>
             </a:r>
           </a:p>
         </p:txBody>
@@ -5897,14 +5953,14 @@
       </p:sp>
       <p:pic>
         <p:nvPicPr>
-          <p:cNvPr id="38" name=""/>
+          <p:cNvPr id="48" name=""/>
           <p:cNvPicPr>
             <a:picLocks xmlns:a="http://schemas.openxmlformats.org/drawingml/2006/main" noChangeAspect="1"/>
           </p:cNvPicPr>
           <p:nvPr/>
         </p:nvPicPr>
         <p:blipFill>
-          <a:blip xmlns:r="http://schemas.openxmlformats.org/officeDocument/2006/relationships" xmlns:a="http://schemas.openxmlformats.org/drawingml/2006/main" r:embed="Rb0bd3e60eb4f4d59"/>
+          <a:blip xmlns:r="http://schemas.openxmlformats.org/officeDocument/2006/relationships" xmlns:a="http://schemas.openxmlformats.org/drawingml/2006/main" r:embed="R18724670b5ef47fd"/>
           <a:stretch xmlns:a="http://schemas.openxmlformats.org/drawingml/2006/main"/>
         </p:blipFill>
         <p:spPr>
@@ -6929,7 +6985,7 @@
       </p:sp>
       <p:cxnSp>
         <p:nvCxnSpPr>
-          <p:cNvPr id="40" name=""/>
+          <p:cNvPr id="54" name=""/>
           <p:cNvCxnSpPr/>
           <p:nvPr/>
         </p:nvCxnSpPr>
@@ -7003,7 +7059,7 @@
                 <a:ea typeface="Aptos"/>
                 <a:cs typeface="Aptos"/>
               </a:rPr>
-              <a:t>PEPPERBALL REPORTING PLATFORM</a:t>
+              <a:t>THOMAS RYAN</a:t>
             </a:r>
           </a:p>
         </p:txBody>
@@ -7069,7 +7125,7 @@
       </p:sp>
       <p:cxnSp>
         <p:nvCxnSpPr>
-          <p:cNvPr id="43" name=""/>
+          <p:cNvPr id="57" name=""/>
           <p:cNvCxnSpPr/>
           <p:nvPr/>
         </p:nvCxnSpPr>
@@ -8084,7 +8140,7 @@
       </p:sp>
       <p:cxnSp>
         <p:nvCxnSpPr>
-          <p:cNvPr id="34" name=""/>
+          <p:cNvPr id="42" name=""/>
           <p:cNvCxnSpPr/>
           <p:nvPr/>
         </p:nvCxnSpPr>
@@ -8158,7 +8214,7 @@
                 <a:ea typeface="Aptos"/>
                 <a:cs typeface="Aptos"/>
               </a:rPr>
-              <a:t>PEPPERBALL REPORTING PLATFORM</a:t>
+              <a:t>THOMAS RYAN</a:t>
             </a:r>
           </a:p>
         </p:txBody>
@@ -9278,7 +9334,7 @@
       </p:sp>
       <p:cxnSp>
         <p:nvCxnSpPr>
-          <p:cNvPr id="31" name=""/>
+          <p:cNvPr id="39" name=""/>
           <p:cNvCxnSpPr/>
           <p:nvPr/>
         </p:nvCxnSpPr>
@@ -9352,7 +9408,7 @@
                 <a:ea typeface="Aptos"/>
                 <a:cs typeface="Aptos"/>
               </a:rPr>
-              <a:t>PEPPERBALL REPORTING PLATFORM</a:t>
+              <a:t>THOMAS RYAN</a:t>
             </a:r>
           </a:p>
         </p:txBody>
@@ -10699,7 +10755,7 @@
       </p:sp>
       <p:cxnSp>
         <p:nvCxnSpPr>
-          <p:cNvPr id="34" name=""/>
+          <p:cNvPr id="50" name=""/>
           <p:cNvCxnSpPr/>
           <p:nvPr/>
         </p:nvCxnSpPr>
@@ -10736,7 +10792,7 @@
         <p:spPr>
           <a:xfrm xmlns:a="http://schemas.openxmlformats.org/drawingml/2006/main">
             <a:off x="400050" y="6419850"/>
-            <a:ext cx="4953000" cy="171450"/>
+            <a:ext cx="10668000" cy="190500"/>
           </a:xfrm>
           <a:prstGeom xmlns:a="http://schemas.openxmlformats.org/drawingml/2006/main" prst="rect">
             <a:avLst/>
@@ -10773,7 +10829,7 @@
                 <a:ea typeface="Aptos"/>
                 <a:cs typeface="Aptos"/>
               </a:rPr>
-              <a:t>ALL RIGHTS RESERVED · SANITIZED PORTFOLIO CASE STUDY</a:t>
+              <a:t>Personal portfolio case study by Thomas Ryan. Not an official PepperBall publication.</a:t>
             </a:r>
           </a:p>
         </p:txBody>

</xml_diff>